<commit_message>
Präsentation: H2 durch MySQL ersetzt
</commit_message>
<xml_diff>
--- a/StudyCards_Praesentation.pptx
+++ b/StudyCards_Praesentation.pptx
@@ -3702,7 +3702,7 @@
                 </a:solidFill>
                 <a:latin typeface="Calibri"/>
               </a:rPr>
-              <a:t>H2 + JDBC</a:t>
+              <a:t>MySQL + JDBC</a:t>
             </a:r>
           </a:p>
         </p:txBody>
@@ -4723,7 +4723,7 @@
                 <a:latin typeface="Calibri"/>
               </a:rPr>
               <a:t>→  JavaFX 21 — Benutzeroberfläche
-→  H2 Database — Datenspeicher
+→  MySQL — Datenspeicher
 →  JDBC — Datenbankzugriff
 →  Maven — Build &amp; Dependencies</a:t>
             </a:r>
@@ -5741,7 +5741,7 @@
                 </a:solidFill>
                 <a:latin typeface="Calibri"/>
               </a:rPr>
-              <a:t>MySQL lokal einzurichten war fehleranfällig und zeitaufwändig.</a:t>
+              <a:t>Datenbank-Verbindung wollte zunächst nicht funktionieren.</a:t>
             </a:r>
           </a:p>
         </p:txBody>
@@ -5820,7 +5820,7 @@
                 </a:solidFill>
                 <a:latin typeface="Calibri"/>
               </a:rPr>
-              <a:t>✓  H2 Embedded DB — kein separater Server nötig</a:t>
+              <a:t>✓  MySQL Connector korrekt eingebunden und JDBC-URL angepasst</a:t>
             </a:r>
           </a:p>
         </p:txBody>
@@ -7578,7 +7578,7 @@
                 </a:solidFill>
                 <a:latin typeface="Courier New"/>
               </a:rPr>
-              <a:t>💾  H2 Datenbank  —  studycards_db.mv.db  (embedded, kein Server nötig)</a:t>
+              <a:t>💾  MySQL Datenbank  —  localhost:3306/studycards</a:t>
             </a:r>
           </a:p>
         </p:txBody>

</xml_diff>